<commit_message>
v1.0.2: sync corrected 19-exemplar roster count, path-traversal hardening, project_root test fix
Re-synced from the monorepo after excluding an unrelated, unfinished
concurrent exemplar (template_formal) from the public roster — the decks
now correctly say '19 public exemplars' rather than a stale 20. Also
brings over the src/ path-traversal and stale-file-cleanup hardening from
the monorepo's red-team pass, and fixes project_root()'s test to accept
this repo's own (hyphenated) directory name.

110/110 tests passing, 98.41% coverage.
</commit_message>
<xml_diff>
--- a/output/pptx/template_template_pitch_long.pptx
+++ b/output/pptx/template_template_pitch_long.pptx
@@ -7233,7 +7233,7 @@
               </a:defRPr>
             </a:pPr>
             <a:r>
-              <a:t>•  projects/templates/ holds all 20 public exemplars: template_active_inference, template_autopoiesis, template_autoresearch_project, template_autoscientists, template_code_project, template_eda_notebook, template_formal, template_gold_refinement, template_literature_meta_analysis, template_madlib, template_methods_paper, template_newspaper, template_pitch_deck, template_pools_rules_tools, template_prose_project, template_search_project, template_sia, template_storybook, template_template, template_textbook.</a:t>
+              <a:t>•  projects/templates/ holds all 19 public exemplars: template_active_inference, template_autopoiesis, template_autoresearch_project, template_autoscientists, template_code_project, template_eda_notebook, template_gold_refinement, template_literature_meta_analysis, template_madlib, template_methods_paper, template_newspaper, template_pitch_deck, template_pools_rules_tools, template_prose_project, template_search_project, template_sia, template_storybook, template_template, template_textbook.</a:t>
             </a:r>
           </a:p>
           <a:p>
@@ -7263,7 +7263,7 @@
               </a:defRPr>
             </a:pPr>
             <a:r>
-              <a:t>•  Neither exemplar's coverage gate or drift check required any special-casing to add — the contract is uniform across all 20 projects, and the folder itself is the evidence, not a claim about it.</a:t>
+              <a:t>•  Neither exemplar's coverage gate or drift check required any special-casing to add — the contract is uniform across all 19 projects, and the folder itself is the evidence, not a claim about it.</a:t>
             </a:r>
           </a:p>
         </p:txBody>
@@ -10118,7 +10118,7 @@
               </a:defRPr>
             </a:pPr>
             <a:r>
-              <a:t>•  Every one of 20 public exemplars is measured independently, not summarized into one repo-wide percentage.</a:t>
+              <a:t>•  Every one of 19 public exemplars is measured independently, not summarized into one repo-wide percentage.</a:t>
             </a:r>
           </a:p>
           <a:p>
@@ -11812,7 +11812,7 @@
               </a:defRPr>
             </a:pPr>
             <a:r>
-              <a:t>•  25 importable subpackages, 668 tracked Python files total under infrastructure/ — a real inventory anyone can `git ls-files` themselves, not a claimed abstraction.</a:t>
+              <a:t>•  25 importable subpackages, 671 tracked Python files total under infrastructure/ — a real inventory anyone can `git ls-files` themselves, not a claimed abstraction.</a:t>
             </a:r>
           </a:p>
           <a:p>
@@ -14746,7 +14746,7 @@
               </a:defRPr>
             </a:pPr>
             <a:r>
-              <a:t>•  One of 20 public exemplar templates in the same monorepo, each independently tested and coverage-gated.</a:t>
+              <a:t>•  One of 19 public exemplar templates in the same monorepo, each independently tested and coverage-gated.</a:t>
             </a:r>
           </a:p>
         </p:txBody>

</xml_diff>

<commit_message>
Sync from template v3.6.0: conditional algorithm2e, exemplar completeness
</commit_message>
<xml_diff>
--- a/output/pptx/template_template_pitch_long.pptx
+++ b/output/pptx/template_template_pitch_long.pptx
@@ -7233,7 +7233,7 @@
               </a:defRPr>
             </a:pPr>
             <a:r>
-              <a:t>•  projects/templates/ holds all 19 public exemplars: template_active_inference, template_autopoiesis, template_autoresearch_project, template_autoscientists, template_code_project, template_eda_notebook, template_gold_refinement, template_literature_meta_analysis, template_madlib, template_methods_paper, template_newspaper, template_pitch_deck, template_pools_rules_tools, template_prose_project, template_search_project, template_sia, template_storybook, template_template, template_textbook.</a:t>
+              <a:t>•  projects/templates/ holds all 23 public exemplars: template_active_inference, template_autopoiesis, template_autoresearch_project, template_autoscientists, template_code_project, template_data_descriptor, template_eda_notebook, template_formal, template_gold_refinement, template_literature_meta_analysis, template_madlib, template_methods_paper, template_newspaper, template_pitch_deck, template_pools_rules_tools, template_prose_project, template_redacted_report, template_registered_report, template_search_project, template_sia, template_storybook, template_template, template_textbook.</a:t>
             </a:r>
           </a:p>
           <a:p>
@@ -7263,7 +7263,7 @@
               </a:defRPr>
             </a:pPr>
             <a:r>
-              <a:t>•  Neither exemplar's coverage gate or drift check required any special-casing to add — the contract is uniform across all 19 projects, and the folder itself is the evidence, not a claim about it.</a:t>
+              <a:t>•  Neither exemplar's coverage gate or drift check required any special-casing to add — the contract is uniform across all 23 projects, and the folder itself is the evidence, not a claim about it.</a:t>
             </a:r>
           </a:p>
         </p:txBody>
@@ -9427,9 +9427,33 @@
           </a:p>
         </p:txBody>
       </p:sp>
-      <p:sp>
-        <p:nvSpPr>
-          <p:cNvPr id="4" name="TextBox 3"/>
+      <p:pic>
+        <p:nvPicPr>
+          <p:cNvPr id="4" name="Picture 3" descr="integrity_stack.png"/>
+          <p:cNvPicPr>
+            <a:picLocks noChangeAspect="1"/>
+          </p:cNvPicPr>
+          <p:nvPr/>
+        </p:nvPicPr>
+        <p:blipFill>
+          <a:blip r:embed="rId2"/>
+          <a:stretch>
+            <a:fillRect/>
+          </a:stretch>
+        </p:blipFill>
+        <p:spPr>
+          <a:xfrm>
+            <a:off x="914400" y="914400"/>
+            <a:ext cx="7315200" cy="4644571"/>
+          </a:xfrm>
+          <a:prstGeom prst="rect">
+            <a:avLst/>
+          </a:prstGeom>
+        </p:spPr>
+      </p:pic>
+      <p:sp>
+        <p:nvSpPr>
+          <p:cNvPr id="5" name="TextBox 4"/>
           <p:cNvSpPr txBox="1"/>
           <p:nvPr/>
         </p:nvSpPr>
@@ -9454,7 +9478,7 @@
                 <a:solidFill>
                   <a:srgbClr val="8A8F99"/>
                 </a:solidFill>
-                <a:hlinkClick r:id="rId2"/>
+                <a:hlinkClick r:id="rId3"/>
               </a:rPr>
               <a:t>Source: projects/templates/template_pitch_deck/src/token_resolution.py</a:t>
             </a:r>
@@ -9463,8 +9487,8 @@
       </p:sp>
       <p:pic>
         <p:nvPicPr>
-          <p:cNvPr id="5" name="Picture 4" descr="image.png">
-            <a:hlinkClick r:id="rId4"/>
+          <p:cNvPr id="6" name="Picture 5" descr="image.png">
+            <a:hlinkClick r:id="rId5"/>
           </p:cNvPr>
           <p:cNvPicPr>
             <a:picLocks noChangeAspect="1"/>
@@ -9472,7 +9496,7 @@
           <p:nvPr/>
         </p:nvPicPr>
         <p:blipFill>
-          <a:blip r:embed="rId3"/>
+          <a:blip r:embed="rId4"/>
           <a:stretch>
             <a:fillRect/>
           </a:stretch>
@@ -10118,7 +10142,7 @@
               </a:defRPr>
             </a:pPr>
             <a:r>
-              <a:t>•  Every one of 19 public exemplars is measured independently, not summarized into one repo-wide percentage.</a:t>
+              <a:t>•  Every one of 23 public exemplars is measured independently, not summarized into one repo-wide percentage.</a:t>
             </a:r>
           </a:p>
           <a:p>
@@ -10329,7 +10353,7 @@
         <p:spPr>
           <a:xfrm>
             <a:off x="914400" y="914400"/>
-            <a:ext cx="7315200" cy="4256116"/>
+            <a:ext cx="7315200" cy="4894534"/>
           </a:xfrm>
           <a:prstGeom prst="rect">
             <a:avLst/>
@@ -11435,7 +11459,7 @@
               </a:defRPr>
             </a:pPr>
             <a:r>
-              <a:t>•  A DOI is reserved through the same infrastructure.publishing pipeline every other exemplar in this monorepo uses — nothing deck-specific to build, only a deposit to make.</a:t>
+              <a:t>•  This deck's DOI is deposited through the same infrastructure.publishing pipeline every other exemplar in this monorepo uses — nothing deck-specific to build, only a deposit to make.</a:t>
             </a:r>
           </a:p>
         </p:txBody>
@@ -11812,7 +11836,7 @@
               </a:defRPr>
             </a:pPr>
             <a:r>
-              <a:t>•  25 importable subpackages, 671 tracked Python files total under infrastructure/ — a real inventory anyone can `git ls-files` themselves, not a claimed abstraction.</a:t>
+              <a:t>•  25 importable subpackages, 673 tracked Python files total under infrastructure/ — a real inventory anyone can `git ls-files` themselves, not a claimed abstraction.</a:t>
             </a:r>
           </a:p>
           <a:p>
@@ -14746,7 +14770,7 @@
               </a:defRPr>
             </a:pPr>
             <a:r>
-              <a:t>•  One of 19 public exemplar templates in the same monorepo, each independently tested and coverage-gated.</a:t>
+              <a:t>•  One of 23 public exemplar templates in the same monorepo, each independently tested and coverage-gated.</a:t>
             </a:r>
           </a:p>
         </p:txBody>

</xml_diff>